<commit_message>
docs(faculdade): os slides deixam de mostrar quem fala e o horário
O rodapé "Tiago · 9:00–10:00" era instrução de ensaio exposta à plateia.
A mesma informação já está nas notas do apresentador de cada slide, que
continuam iguais. Saem as 7 chamadas e a função; a legenda "M = medido"
do slide 7 fica, porque essa é para quem assiste.
</commit_message>
<xml_diff>
--- a/Faculdade/SDIoT_Atividade_Redes/apresentacao/Rede_WaveAI_Apresentacao.pptx
+++ b/Faculdade/SDIoT_Atividade_Redes/apresentacao/Rede_WaveAI_Apresentacao.pptx
@@ -3167,45 +3167,6 @@
           </a:p>
         </p:txBody>
       </p:sp>
-      <p:sp>
-        <p:nvSpPr>
-          <p:cNvPr id="35" name="Text 33"/>
-          <p:cNvSpPr txBox="1"/>
-          <p:nvPr/>
-        </p:nvSpPr>
-        <p:spPr>
-          <a:xfrm>
-            <a:off x="457200" y="4754880"/>
-            <a:ext cx="8229600" cy="228600"/>
-          </a:xfrm>
-          <a:prstGeom prst="rect">
-            <a:avLst/>
-          </a:prstGeom>
-          <a:noFill/>
-          <a:ln/>
-        </p:spPr>
-        <p:txBody>
-          <a:bodyPr wrap="square" lIns="0" tIns="0" rIns="0" bIns="0" rtlCol="0" anchor="ctr"/>
-          <a:lstStyle/>
-          <a:p>
-            <a:pPr algn="r" indent="0" marL="0">
-              <a:buNone/>
-            </a:pPr>
-            <a:r>
-              <a:rPr lang="en-US" sz="1000" dirty="0">
-                <a:solidFill>
-                  <a:srgbClr val="5B6B7F"/>
-                </a:solidFill>
-                <a:latin typeface="Calibri" pitchFamily="34" charset="0"/>
-                <a:ea typeface="Calibri" pitchFamily="34" charset="-122"/>
-                <a:cs typeface="Calibri" pitchFamily="34" charset="-120"/>
-              </a:rPr>
-              <a:t>Tiago · 0:15–2:00</a:t>
-            </a:r>
-            <a:endParaRPr lang="en-US" sz="1000" dirty="0"/>
-          </a:p>
-        </p:txBody>
-      </p:sp>
     </p:spTree>
   </p:cSld>
   <p:clrMapOvr>
@@ -6464,45 +6425,6 @@
           </a:graphicData>
         </a:graphic>
       </p:graphicFrame>
-      <p:sp>
-        <p:nvSpPr>
-          <p:cNvPr id="4" name="Text 1"/>
-          <p:cNvSpPr txBox="1"/>
-          <p:nvPr/>
-        </p:nvSpPr>
-        <p:spPr>
-          <a:xfrm>
-            <a:off x="457200" y="4754880"/>
-            <a:ext cx="8229600" cy="228600"/>
-          </a:xfrm>
-          <a:prstGeom prst="rect">
-            <a:avLst/>
-          </a:prstGeom>
-          <a:noFill/>
-          <a:ln/>
-        </p:spPr>
-        <p:txBody>
-          <a:bodyPr wrap="square" lIns="0" tIns="0" rIns="0" bIns="0" rtlCol="0" anchor="ctr"/>
-          <a:lstStyle/>
-          <a:p>
-            <a:pPr algn="r" indent="0" marL="0">
-              <a:buNone/>
-            </a:pPr>
-            <a:r>
-              <a:rPr lang="en-US" sz="1000" dirty="0">
-                <a:solidFill>
-                  <a:srgbClr val="5B6B7F"/>
-                </a:solidFill>
-                <a:latin typeface="Calibri" pitchFamily="34" charset="0"/>
-                <a:ea typeface="Calibri" pitchFamily="34" charset="-122"/>
-                <a:cs typeface="Calibri" pitchFamily="34" charset="-120"/>
-              </a:rPr>
-              <a:t>Gustavo · 3:30–4:30</a:t>
-            </a:r>
-            <a:endParaRPr lang="en-US" sz="1000" dirty="0"/>
-          </a:p>
-        </p:txBody>
-      </p:sp>
     </p:spTree>
   </p:cSld>
   <p:clrMapOvr>
@@ -7040,45 +6962,6 @@
           </a:p>
         </p:txBody>
       </p:sp>
-      <p:sp>
-        <p:nvSpPr>
-          <p:cNvPr id="14" name="Text 12"/>
-          <p:cNvSpPr txBox="1"/>
-          <p:nvPr/>
-        </p:nvSpPr>
-        <p:spPr>
-          <a:xfrm>
-            <a:off x="457200" y="4754880"/>
-            <a:ext cx="8229600" cy="228600"/>
-          </a:xfrm>
-          <a:prstGeom prst="rect">
-            <a:avLst/>
-          </a:prstGeom>
-          <a:noFill/>
-          <a:ln/>
-        </p:spPr>
-        <p:txBody>
-          <a:bodyPr wrap="square" lIns="0" tIns="0" rIns="0" bIns="0" rtlCol="0" anchor="ctr"/>
-          <a:lstStyle/>
-          <a:p>
-            <a:pPr algn="r" indent="0" marL="0">
-              <a:buNone/>
-            </a:pPr>
-            <a:r>
-              <a:rPr lang="en-US" sz="1000" dirty="0">
-                <a:solidFill>
-                  <a:srgbClr val="5B6B7F"/>
-                </a:solidFill>
-                <a:latin typeface="Calibri" pitchFamily="34" charset="0"/>
-                <a:ea typeface="Calibri" pitchFamily="34" charset="-122"/>
-                <a:cs typeface="Calibri" pitchFamily="34" charset="-120"/>
-              </a:rPr>
-              <a:t>Nickolas · 4:30–5:15</a:t>
-            </a:r>
-            <a:endParaRPr lang="en-US" sz="1000" dirty="0"/>
-          </a:p>
-        </p:txBody>
-      </p:sp>
     </p:spTree>
   </p:cSld>
   <p:clrMapOvr>
@@ -7941,45 +7824,6 @@
           </a:p>
         </p:txBody>
       </p:sp>
-      <p:sp>
-        <p:nvSpPr>
-          <p:cNvPr id="26" name="Text 24"/>
-          <p:cNvSpPr txBox="1"/>
-          <p:nvPr/>
-        </p:nvSpPr>
-        <p:spPr>
-          <a:xfrm>
-            <a:off x="457200" y="4754880"/>
-            <a:ext cx="8229600" cy="228600"/>
-          </a:xfrm>
-          <a:prstGeom prst="rect">
-            <a:avLst/>
-          </a:prstGeom>
-          <a:noFill/>
-          <a:ln/>
-        </p:spPr>
-        <p:txBody>
-          <a:bodyPr wrap="square" lIns="0" tIns="0" rIns="0" bIns="0" rtlCol="0" anchor="ctr"/>
-          <a:lstStyle/>
-          <a:p>
-            <a:pPr algn="r" indent="0" marL="0">
-              <a:buNone/>
-            </a:pPr>
-            <a:r>
-              <a:rPr lang="en-US" sz="1000" dirty="0">
-                <a:solidFill>
-                  <a:srgbClr val="7F90A8"/>
-                </a:solidFill>
-                <a:latin typeface="Calibri" pitchFamily="34" charset="0"/>
-                <a:ea typeface="Calibri" pitchFamily="34" charset="-122"/>
-                <a:cs typeface="Calibri" pitchFamily="34" charset="-120"/>
-              </a:rPr>
-              <a:t>Nickolas · 5:15–7:15</a:t>
-            </a:r>
-            <a:endParaRPr lang="en-US" sz="1000" dirty="0"/>
-          </a:p>
-        </p:txBody>
-      </p:sp>
     </p:spTree>
   </p:cSld>
   <p:clrMapOvr>
@@ -8726,45 +8570,6 @@
           </a:p>
         </p:txBody>
       </p:sp>
-      <p:sp>
-        <p:nvSpPr>
-          <p:cNvPr id="18" name="Text 16"/>
-          <p:cNvSpPr txBox="1"/>
-          <p:nvPr/>
-        </p:nvSpPr>
-        <p:spPr>
-          <a:xfrm>
-            <a:off x="457200" y="4754880"/>
-            <a:ext cx="8229600" cy="228600"/>
-          </a:xfrm>
-          <a:prstGeom prst="rect">
-            <a:avLst/>
-          </a:prstGeom>
-          <a:noFill/>
-          <a:ln/>
-        </p:spPr>
-        <p:txBody>
-          <a:bodyPr wrap="square" lIns="0" tIns="0" rIns="0" bIns="0" rtlCol="0" anchor="ctr"/>
-          <a:lstStyle/>
-          <a:p>
-            <a:pPr algn="r" indent="0" marL="0">
-              <a:buNone/>
-            </a:pPr>
-            <a:r>
-              <a:rPr lang="en-US" sz="1000" dirty="0">
-                <a:solidFill>
-                  <a:srgbClr val="5B6B7F"/>
-                </a:solidFill>
-                <a:latin typeface="Calibri" pitchFamily="34" charset="0"/>
-                <a:ea typeface="Calibri" pitchFamily="34" charset="-122"/>
-                <a:cs typeface="Calibri" pitchFamily="34" charset="-120"/>
-              </a:rPr>
-              <a:t>Gustavo · 7:15–8:00</a:t>
-            </a:r>
-            <a:endParaRPr lang="en-US" sz="1000" dirty="0"/>
-          </a:p>
-        </p:txBody>
-      </p:sp>
     </p:spTree>
   </p:cSld>
   <p:clrMapOvr>
@@ -9936,45 +9741,6 @@
           </a:p>
         </p:txBody>
       </p:sp>
-      <p:sp>
-        <p:nvSpPr>
-          <p:cNvPr id="33" name="Text 31"/>
-          <p:cNvSpPr txBox="1"/>
-          <p:nvPr/>
-        </p:nvSpPr>
-        <p:spPr>
-          <a:xfrm>
-            <a:off x="457200" y="4754880"/>
-            <a:ext cx="8229600" cy="228600"/>
-          </a:xfrm>
-          <a:prstGeom prst="rect">
-            <a:avLst/>
-          </a:prstGeom>
-          <a:noFill/>
-          <a:ln/>
-        </p:spPr>
-        <p:txBody>
-          <a:bodyPr wrap="square" lIns="0" tIns="0" rIns="0" bIns="0" rtlCol="0" anchor="ctr"/>
-          <a:lstStyle/>
-          <a:p>
-            <a:pPr algn="r" indent="0" marL="0">
-              <a:buNone/>
-            </a:pPr>
-            <a:r>
-              <a:rPr lang="en-US" sz="1000" dirty="0">
-                <a:solidFill>
-                  <a:srgbClr val="5B6B7F"/>
-                </a:solidFill>
-                <a:latin typeface="Calibri" pitchFamily="34" charset="0"/>
-                <a:ea typeface="Calibri" pitchFamily="34" charset="-122"/>
-                <a:cs typeface="Calibri" pitchFamily="34" charset="-120"/>
-              </a:rPr>
-              <a:t>Nickolas · 8:00–9:00</a:t>
-            </a:r>
-            <a:endParaRPr lang="en-US" sz="1000" dirty="0"/>
-          </a:p>
-        </p:txBody>
-      </p:sp>
     </p:spTree>
   </p:cSld>
   <p:clrMapOvr>
@@ -10711,45 +10477,6 @@
               <a:t>Headset de consumo usado sentado; o tempo de cada amostra sai da contagem, não de um relógio.</a:t>
             </a:r>
             <a:endParaRPr lang="en-US" sz="1200" dirty="0"/>
-          </a:p>
-        </p:txBody>
-      </p:sp>
-      <p:sp>
-        <p:nvSpPr>
-          <p:cNvPr id="21" name="Text 19"/>
-          <p:cNvSpPr txBox="1"/>
-          <p:nvPr/>
-        </p:nvSpPr>
-        <p:spPr>
-          <a:xfrm>
-            <a:off x="457200" y="4754880"/>
-            <a:ext cx="8229600" cy="228600"/>
-          </a:xfrm>
-          <a:prstGeom prst="rect">
-            <a:avLst/>
-          </a:prstGeom>
-          <a:noFill/>
-          <a:ln/>
-        </p:spPr>
-        <p:txBody>
-          <a:bodyPr wrap="square" lIns="0" tIns="0" rIns="0" bIns="0" rtlCol="0" anchor="ctr"/>
-          <a:lstStyle/>
-          <a:p>
-            <a:pPr algn="r" indent="0" marL="0">
-              <a:buNone/>
-            </a:pPr>
-            <a:r>
-              <a:rPr lang="en-US" sz="1000" dirty="0">
-                <a:solidFill>
-                  <a:srgbClr val="5B6B7F"/>
-                </a:solidFill>
-                <a:latin typeface="Calibri" pitchFamily="34" charset="0"/>
-                <a:ea typeface="Calibri" pitchFamily="34" charset="-122"/>
-                <a:cs typeface="Calibri" pitchFamily="34" charset="-120"/>
-              </a:rPr>
-              <a:t>Tiago · 9:00–10:00</a:t>
-            </a:r>
-            <a:endParaRPr lang="en-US" sz="1000" dirty="0"/>
           </a:p>
         </p:txBody>
       </p:sp>

</xml_diff>